<commit_message>
feat: actual PPTX generation, combined CLI, PNG export stub
- pptx_writer.py: Real PPTX generation using template placeholders
- convert_pptx.py: Combined CLI converting PPTX to single reel output
- png_export.py: LibreOffice headless export stub
- rule_engine.py: Fixed content type routing to match template config
- STATUS.md: Updated with completed PPTX generation status
- Multiple test scripts for inspection and validation
- Template config updated with correct content type routing keys
</commit_message>
<xml_diff>
--- a/python/reel_converter/templates/reel_clean.pptx
+++ b/python/reel_converter/templates/reel_clean.pptx
@@ -3094,7 +3094,35 @@
       <p:grpSpPr/>
       <p:sp>
         <p:nvSpPr>
-          <p:cNvPr id="4" name="Rectangle 3"/>
+          <p:cNvPr id="2" name="Title 1"/>
+          <p:cNvSpPr>
+            <a:spLocks noGrp="1"/>
+          </p:cNvSpPr>
+          <p:nvPr>
+            <p:ph type="title"/>
+          </p:nvPr>
+        </p:nvSpPr>
+        <p:spPr/>
+        <p:txBody>
+          <a:bodyPr/>
+          <a:lstStyle/>
+          <a:p>
+            <a:pPr algn="ctr">
+              <a:defRPr sz="4800" b="1">
+                <a:solidFill>
+                  <a:srgbClr val="FFFFFF"/>
+                </a:solidFill>
+              </a:defRPr>
+            </a:pPr>
+            <a:r>
+              <a:t>Title Headline</a:t>
+            </a:r>
+          </a:p>
+        </p:txBody>
+      </p:sp>
+      <p:sp>
+        <p:nvSpPr>
+          <p:cNvPr id="3" name="Rectangle 2"/>
           <p:cNvSpPr/>
           <p:nvPr/>
         </p:nvSpPr>
@@ -3135,76 +3163,6 @@
           </a:p>
         </p:txBody>
       </p:sp>
-      <p:sp>
-        <p:nvSpPr>
-          <p:cNvPr id="2" name="TextBox 1"/>
-          <p:cNvSpPr txBox="1"/>
-          <p:nvPr/>
-        </p:nvSpPr>
-        <p:spPr>
-          <a:xfrm>
-            <a:off x="514350" y="2263140"/>
-            <a:ext cx="4114800" cy="1485900"/>
-          </a:xfrm>
-          <a:prstGeom prst="rect">
-            <a:avLst/>
-          </a:prstGeom>
-          <a:noFill/>
-        </p:spPr>
-        <p:txBody>
-          <a:bodyPr wrap="square">
-            <a:spAutoFit/>
-          </a:bodyPr>
-          <a:lstStyle/>
-          <a:p>
-            <a:pPr algn="ctr">
-              <a:defRPr sz="3779" b="1">
-                <a:solidFill>
-                  <a:srgbClr val="FFFFFF"/>
-                </a:solidFill>
-              </a:defRPr>
-            </a:pPr>
-            <a:r>
-              <a:t>Title Headline</a:t>
-            </a:r>
-          </a:p>
-        </p:txBody>
-      </p:sp>
-      <p:sp>
-        <p:nvSpPr>
-          <p:cNvPr id="3" name="TextBox 2"/>
-          <p:cNvSpPr txBox="1"/>
-          <p:nvPr/>
-        </p:nvSpPr>
-        <p:spPr>
-          <a:xfrm>
-            <a:off x="514350" y="4046220"/>
-            <a:ext cx="4114800" cy="891540"/>
-          </a:xfrm>
-          <a:prstGeom prst="rect">
-            <a:avLst/>
-          </a:prstGeom>
-          <a:noFill/>
-        </p:spPr>
-        <p:txBody>
-          <a:bodyPr wrap="square">
-            <a:spAutoFit/>
-          </a:bodyPr>
-          <a:lstStyle/>
-          <a:p>
-            <a:pPr algn="ctr">
-              <a:defRPr sz="1889">
-                <a:solidFill>
-                  <a:srgbClr val="FFFFFF"/>
-                </a:solidFill>
-              </a:defRPr>
-            </a:pPr>
-            <a:r>
-              <a:t>Subtitle text goes here</a:t>
-            </a:r>
-          </a:p>
-        </p:txBody>
-      </p:sp>
     </p:spTree>
   </p:cSld>
   <p:clrMapOvr>
@@ -3225,7 +3183,75 @@
       <p:grpSpPr/>
       <p:sp>
         <p:nvSpPr>
-          <p:cNvPr id="5" name="Rectangle 4"/>
+          <p:cNvPr id="2" name="Title 1"/>
+          <p:cNvSpPr>
+            <a:spLocks noGrp="1"/>
+          </p:cNvSpPr>
+          <p:nvPr>
+            <p:ph type="title"/>
+          </p:nvPr>
+        </p:nvSpPr>
+        <p:spPr/>
+        <p:txBody>
+          <a:bodyPr/>
+          <a:lstStyle/>
+          <a:p>
+            <a:pPr algn="ctr">
+              <a:defRPr sz="7200" b="1">
+                <a:solidFill>
+                  <a:srgbClr val="0196FF"/>
+                </a:solidFill>
+              </a:defRPr>
+            </a:pPr>
+            <a:r>
+              <a:t>$12M</a:t>
+            </a:r>
+          </a:p>
+        </p:txBody>
+      </p:sp>
+      <p:sp>
+        <p:nvSpPr>
+          <p:cNvPr id="3" name="Content Placeholder 2"/>
+          <p:cNvSpPr>
+            <a:spLocks noGrp="1"/>
+          </p:cNvSpPr>
+          <p:nvPr>
+            <p:ph idx="1"/>
+          </p:nvPr>
+        </p:nvSpPr>
+        <p:spPr/>
+        <p:txBody>
+          <a:bodyPr/>
+          <a:lstStyle/>
+          <a:p>
+            <a:pPr algn="ctr">
+              <a:defRPr sz="3600" b="1">
+                <a:solidFill>
+                  <a:srgbClr val="FFFFFF"/>
+                </a:solidFill>
+              </a:defRPr>
+            </a:pPr>
+            <a:r>
+              <a:t>Revenue</a:t>
+            </a:r>
+          </a:p>
+          <a:p>
+            <a:pPr>
+              <a:defRPr sz="2400">
+                <a:solidFill>
+                  <a:srgbClr val="FFFFFF"/>
+                </a:solidFill>
+              </a:defRPr>
+            </a:pPr>
+            <a:r>
+              <a:t>+15% Year over Year</a:t>
+            </a:r>
+          </a:p>
+        </p:txBody>
+      </p:sp>
+      <p:sp>
+        <p:nvSpPr>
+          <p:cNvPr id="4" name="Rectangle 3"/>
           <p:cNvSpPr/>
           <p:nvPr/>
         </p:nvSpPr>
@@ -3266,111 +3292,6 @@
           </a:p>
         </p:txBody>
       </p:sp>
-      <p:sp>
-        <p:nvSpPr>
-          <p:cNvPr id="2" name="TextBox 1"/>
-          <p:cNvSpPr txBox="1"/>
-          <p:nvPr/>
-        </p:nvSpPr>
-        <p:spPr>
-          <a:xfrm>
-            <a:off x="514350" y="1965960"/>
-            <a:ext cx="4114800" cy="2080259"/>
-          </a:xfrm>
-          <a:prstGeom prst="rect">
-            <a:avLst/>
-          </a:prstGeom>
-          <a:noFill/>
-        </p:spPr>
-        <p:txBody>
-          <a:bodyPr wrap="square">
-            <a:spAutoFit/>
-          </a:bodyPr>
-          <a:lstStyle/>
-          <a:p>
-            <a:pPr algn="ctr">
-              <a:defRPr sz="5669" b="1">
-                <a:solidFill>
-                  <a:srgbClr val="0196FF"/>
-                </a:solidFill>
-              </a:defRPr>
-            </a:pPr>
-            <a:r>
-              <a:t>$12M</a:t>
-            </a:r>
-          </a:p>
-        </p:txBody>
-      </p:sp>
-      <p:sp>
-        <p:nvSpPr>
-          <p:cNvPr id="3" name="TextBox 2"/>
-          <p:cNvSpPr txBox="1"/>
-          <p:nvPr/>
-        </p:nvSpPr>
-        <p:spPr>
-          <a:xfrm>
-            <a:off x="514350" y="4343400"/>
-            <a:ext cx="4114800" cy="713232"/>
-          </a:xfrm>
-          <a:prstGeom prst="rect">
-            <a:avLst/>
-          </a:prstGeom>
-          <a:noFill/>
-        </p:spPr>
-        <p:txBody>
-          <a:bodyPr wrap="square">
-            <a:spAutoFit/>
-          </a:bodyPr>
-          <a:lstStyle/>
-          <a:p>
-            <a:pPr algn="ctr">
-              <a:defRPr sz="2834" b="1">
-                <a:solidFill>
-                  <a:srgbClr val="FFFFFF"/>
-                </a:solidFill>
-              </a:defRPr>
-            </a:pPr>
-            <a:r>
-              <a:t>Revenue</a:t>
-            </a:r>
-          </a:p>
-        </p:txBody>
-      </p:sp>
-      <p:sp>
-        <p:nvSpPr>
-          <p:cNvPr id="4" name="TextBox 3"/>
-          <p:cNvSpPr txBox="1"/>
-          <p:nvPr/>
-        </p:nvSpPr>
-        <p:spPr>
-          <a:xfrm>
-            <a:off x="514350" y="5234940"/>
-            <a:ext cx="4114800" cy="594360"/>
-          </a:xfrm>
-          <a:prstGeom prst="rect">
-            <a:avLst/>
-          </a:prstGeom>
-          <a:noFill/>
-        </p:spPr>
-        <p:txBody>
-          <a:bodyPr wrap="square">
-            <a:spAutoFit/>
-          </a:bodyPr>
-          <a:lstStyle/>
-          <a:p>
-            <a:pPr algn="ctr">
-              <a:defRPr sz="1889">
-                <a:solidFill>
-                  <a:srgbClr val="FFFFFF"/>
-                </a:solidFill>
-              </a:defRPr>
-            </a:pPr>
-            <a:r>
-              <a:t>+15% Year over Year</a:t>
-            </a:r>
-          </a:p>
-        </p:txBody>
-      </p:sp>
     </p:spTree>
   </p:cSld>
   <p:clrMapOvr>
@@ -3391,7 +3312,87 @@
       <p:grpSpPr/>
       <p:sp>
         <p:nvSpPr>
-          <p:cNvPr id="6" name="Rectangle 5"/>
+          <p:cNvPr id="2" name="Title 1"/>
+          <p:cNvSpPr>
+            <a:spLocks noGrp="1"/>
+          </p:cNvSpPr>
+          <p:nvPr>
+            <p:ph type="title"/>
+          </p:nvPr>
+        </p:nvSpPr>
+        <p:spPr/>
+        <p:txBody>
+          <a:bodyPr/>
+          <a:lstStyle/>
+          <a:p>
+            <a:pPr algn="l">
+              <a:defRPr sz="4000" b="1">
+                <a:solidFill>
+                  <a:srgbClr val="FFFFFF"/>
+                </a:solidFill>
+              </a:defRPr>
+            </a:pPr>
+            <a:r>
+              <a:t>Key Points</a:t>
+            </a:r>
+          </a:p>
+        </p:txBody>
+      </p:sp>
+      <p:sp>
+        <p:nvSpPr>
+          <p:cNvPr id="3" name="Content Placeholder 2"/>
+          <p:cNvSpPr>
+            <a:spLocks noGrp="1"/>
+          </p:cNvSpPr>
+          <p:nvPr>
+            <p:ph idx="1"/>
+          </p:nvPr>
+        </p:nvSpPr>
+        <p:spPr/>
+        <p:txBody>
+          <a:bodyPr/>
+          <a:lstStyle/>
+          <a:p>
+            <a:pPr>
+              <a:defRPr sz="2800">
+                <a:solidFill>
+                  <a:srgbClr val="FFFFFF"/>
+                </a:solidFill>
+              </a:defRPr>
+            </a:pPr>
+            <a:r>
+              <a:t>First bullet point</a:t>
+            </a:r>
+          </a:p>
+          <a:p>
+            <a:pPr>
+              <a:defRPr sz="2800">
+                <a:solidFill>
+                  <a:srgbClr val="FFFFFF"/>
+                </a:solidFill>
+              </a:defRPr>
+            </a:pPr>
+            <a:r>
+              <a:t>Second bullet point</a:t>
+            </a:r>
+          </a:p>
+          <a:p>
+            <a:pPr>
+              <a:defRPr sz="2800">
+                <a:solidFill>
+                  <a:srgbClr val="FFFFFF"/>
+                </a:solidFill>
+              </a:defRPr>
+            </a:pPr>
+            <a:r>
+              <a:t>Third bullet point</a:t>
+            </a:r>
+          </a:p>
+        </p:txBody>
+      </p:sp>
+      <p:sp>
+        <p:nvSpPr>
+          <p:cNvPr id="4" name="Rectangle 3"/>
           <p:cNvSpPr/>
           <p:nvPr/>
         </p:nvSpPr>
@@ -3432,146 +3433,6 @@
           </a:p>
         </p:txBody>
       </p:sp>
-      <p:sp>
-        <p:nvSpPr>
-          <p:cNvPr id="2" name="TextBox 1"/>
-          <p:cNvSpPr txBox="1"/>
-          <p:nvPr/>
-        </p:nvSpPr>
-        <p:spPr>
-          <a:xfrm>
-            <a:off x="514350" y="1668780"/>
-            <a:ext cx="4114800" cy="891540"/>
-          </a:xfrm>
-          <a:prstGeom prst="rect">
-            <a:avLst/>
-          </a:prstGeom>
-          <a:noFill/>
-        </p:spPr>
-        <p:txBody>
-          <a:bodyPr wrap="square">
-            <a:spAutoFit/>
-          </a:bodyPr>
-          <a:lstStyle/>
-          <a:p>
-            <a:pPr algn="l">
-              <a:defRPr sz="3149" b="1">
-                <a:solidFill>
-                  <a:srgbClr val="FFFFFF"/>
-                </a:solidFill>
-              </a:defRPr>
-            </a:pPr>
-            <a:r>
-              <a:t>Key Points</a:t>
-            </a:r>
-          </a:p>
-        </p:txBody>
-      </p:sp>
-      <p:sp>
-        <p:nvSpPr>
-          <p:cNvPr id="3" name="TextBox 2"/>
-          <p:cNvSpPr txBox="1"/>
-          <p:nvPr/>
-        </p:nvSpPr>
-        <p:spPr>
-          <a:xfrm>
-            <a:off x="514350" y="2857500"/>
-            <a:ext cx="4114800" cy="1069848"/>
-          </a:xfrm>
-          <a:prstGeom prst="rect">
-            <a:avLst/>
-          </a:prstGeom>
-          <a:noFill/>
-        </p:spPr>
-        <p:txBody>
-          <a:bodyPr wrap="square">
-            <a:spAutoFit/>
-          </a:bodyPr>
-          <a:lstStyle/>
-          <a:p>
-            <a:pPr algn="l">
-              <a:defRPr sz="2204">
-                <a:solidFill>
-                  <a:srgbClr val="FFFFFF"/>
-                </a:solidFill>
-              </a:defRPr>
-            </a:pPr>
-            <a:r>
-              <a:t>• First bullet point here</a:t>
-            </a:r>
-          </a:p>
-        </p:txBody>
-      </p:sp>
-      <p:sp>
-        <p:nvSpPr>
-          <p:cNvPr id="4" name="TextBox 3"/>
-          <p:cNvSpPr txBox="1"/>
-          <p:nvPr/>
-        </p:nvSpPr>
-        <p:spPr>
-          <a:xfrm>
-            <a:off x="514350" y="4224528"/>
-            <a:ext cx="4114800" cy="1069848"/>
-          </a:xfrm>
-          <a:prstGeom prst="rect">
-            <a:avLst/>
-          </a:prstGeom>
-          <a:noFill/>
-        </p:spPr>
-        <p:txBody>
-          <a:bodyPr wrap="square">
-            <a:spAutoFit/>
-          </a:bodyPr>
-          <a:lstStyle/>
-          <a:p>
-            <a:pPr algn="l">
-              <a:defRPr sz="2204">
-                <a:solidFill>
-                  <a:srgbClr val="FFFFFF"/>
-                </a:solidFill>
-              </a:defRPr>
-            </a:pPr>
-            <a:r>
-              <a:t>• Second bullet point here</a:t>
-            </a:r>
-          </a:p>
-        </p:txBody>
-      </p:sp>
-      <p:sp>
-        <p:nvSpPr>
-          <p:cNvPr id="5" name="TextBox 4"/>
-          <p:cNvSpPr txBox="1"/>
-          <p:nvPr/>
-        </p:nvSpPr>
-        <p:spPr>
-          <a:xfrm>
-            <a:off x="514350" y="5591556"/>
-            <a:ext cx="4114800" cy="1069848"/>
-          </a:xfrm>
-          <a:prstGeom prst="rect">
-            <a:avLst/>
-          </a:prstGeom>
-          <a:noFill/>
-        </p:spPr>
-        <p:txBody>
-          <a:bodyPr wrap="square">
-            <a:spAutoFit/>
-          </a:bodyPr>
-          <a:lstStyle/>
-          <a:p>
-            <a:pPr algn="l">
-              <a:defRPr sz="2204">
-                <a:solidFill>
-                  <a:srgbClr val="FFFFFF"/>
-                </a:solidFill>
-              </a:defRPr>
-            </a:pPr>
-            <a:r>
-              <a:t>• Third bullet point here</a:t>
-            </a:r>
-          </a:p>
-        </p:txBody>
-      </p:sp>
     </p:spTree>
   </p:cSld>
   <p:clrMapOvr>
@@ -3592,7 +3453,68 @@
       <p:grpSpPr/>
       <p:sp>
         <p:nvSpPr>
-          <p:cNvPr id="4" name="Rectangle 3"/>
+          <p:cNvPr id="2" name="Title 1"/>
+          <p:cNvSpPr>
+            <a:spLocks noGrp="1"/>
+          </p:cNvSpPr>
+          <p:nvPr>
+            <p:ph type="title"/>
+          </p:nvPr>
+        </p:nvSpPr>
+        <p:spPr/>
+        <p:txBody>
+          <a:bodyPr/>
+          <a:lstStyle/>
+          <a:p>
+            <a:pPr algn="ctr">
+              <a:defRPr sz="2800">
+                <a:solidFill>
+                  <a:srgbClr val="FFFFFF"/>
+                </a:solidFill>
+              </a:defRPr>
+            </a:pPr>
+            <a:r>
+              <a:t>Image Caption</a:t>
+            </a:r>
+          </a:p>
+        </p:txBody>
+      </p:sp>
+      <p:sp>
+        <p:nvSpPr>
+          <p:cNvPr id="3" name="Picture Placeholder 2"/>
+          <p:cNvSpPr>
+            <a:spLocks noGrp="1"/>
+          </p:cNvSpPr>
+          <p:nvPr>
+            <p:ph type="pic" idx="1"/>
+          </p:nvPr>
+        </p:nvSpPr>
+        <p:spPr>
+          <a:solidFill>
+            <a:srgbClr val="333333"/>
+          </a:solidFill>
+        </p:spPr>
+      </p:sp>
+      <p:sp>
+        <p:nvSpPr>
+          <p:cNvPr id="4" name="Text Placeholder 3"/>
+          <p:cNvSpPr>
+            <a:spLocks noGrp="1"/>
+          </p:cNvSpPr>
+          <p:nvPr>
+            <p:ph type="body" idx="2" sz="half"/>
+          </p:nvPr>
+        </p:nvSpPr>
+        <p:spPr/>
+        <p:txBody>
+          <a:bodyPr/>
+          <a:lstStyle/>
+          <a:p/>
+        </p:txBody>
+      </p:sp>
+      <p:sp>
+        <p:nvSpPr>
+          <p:cNvPr id="5" name="Rectangle 4"/>
           <p:cNvSpPr/>
           <p:nvPr/>
         </p:nvSpPr>
@@ -3633,86 +3555,6 @@
           </a:p>
         </p:txBody>
       </p:sp>
-      <p:sp>
-        <p:nvSpPr>
-          <p:cNvPr id="2" name="Rectangle 1"/>
-          <p:cNvSpPr/>
-          <p:nvPr/>
-        </p:nvSpPr>
-        <p:spPr>
-          <a:xfrm>
-            <a:off x="257175" y="1668780"/>
-            <a:ext cx="4629150" cy="4160519"/>
-          </a:xfrm>
-          <a:prstGeom prst="rect">
-            <a:avLst/>
-          </a:prstGeom>
-          <a:solidFill>
-            <a:srgbClr val="333333"/>
-          </a:solidFill>
-          <a:ln>
-            <a:solidFill>
-              <a:srgbClr val="0196FF"/>
-            </a:solidFill>
-          </a:ln>
-        </p:spPr>
-        <p:style>
-          <a:lnRef idx="1">
-            <a:schemeClr val="accent1"/>
-          </a:lnRef>
-          <a:fillRef idx="3">
-            <a:schemeClr val="accent1"/>
-          </a:fillRef>
-          <a:effectRef idx="2">
-            <a:schemeClr val="accent1"/>
-          </a:effectRef>
-          <a:fontRef idx="minor">
-            <a:schemeClr val="lt1"/>
-          </a:fontRef>
-        </p:style>
-        <p:txBody>
-          <a:bodyPr rtlCol="0" anchor="ctr"/>
-          <a:lstStyle/>
-          <a:p>
-            <a:pPr algn="ctr"/>
-          </a:p>
-        </p:txBody>
-      </p:sp>
-      <p:sp>
-        <p:nvSpPr>
-          <p:cNvPr id="3" name="TextBox 2"/>
-          <p:cNvSpPr txBox="1"/>
-          <p:nvPr/>
-        </p:nvSpPr>
-        <p:spPr>
-          <a:xfrm>
-            <a:off x="514350" y="6126480"/>
-            <a:ext cx="4114800" cy="713232"/>
-          </a:xfrm>
-          <a:prstGeom prst="rect">
-            <a:avLst/>
-          </a:prstGeom>
-          <a:noFill/>
-        </p:spPr>
-        <p:txBody>
-          <a:bodyPr wrap="square">
-            <a:spAutoFit/>
-          </a:bodyPr>
-          <a:lstStyle/>
-          <a:p>
-            <a:pPr algn="ctr">
-              <a:defRPr sz="2204">
-                <a:solidFill>
-                  <a:srgbClr val="FFFFFF"/>
-                </a:solidFill>
-              </a:defRPr>
-            </a:pPr>
-            <a:r>
-              <a:t>Image Caption</a:t>
-            </a:r>
-          </a:p>
-        </p:txBody>
-      </p:sp>
     </p:spTree>
   </p:cSld>
   <p:clrMapOvr>
@@ -3733,7 +3575,35 @@
       <p:grpSpPr/>
       <p:sp>
         <p:nvSpPr>
-          <p:cNvPr id="5" name="Rectangle 4"/>
+          <p:cNvPr id="2" name="Title 1"/>
+          <p:cNvSpPr>
+            <a:spLocks noGrp="1"/>
+          </p:cNvSpPr>
+          <p:nvPr>
+            <p:ph type="title"/>
+          </p:nvPr>
+        </p:nvSpPr>
+        <p:spPr/>
+        <p:txBody>
+          <a:bodyPr/>
+          <a:lstStyle/>
+          <a:p>
+            <a:pPr algn="ctr">
+              <a:defRPr sz="4800" b="1">
+                <a:solidFill>
+                  <a:srgbClr val="FFFFFF"/>
+                </a:solidFill>
+              </a:defRPr>
+            </a:pPr>
+            <a:r>
+              <a:t>Call to Action</a:t>
+            </a:r>
+          </a:p>
+        </p:txBody>
+      </p:sp>
+      <p:sp>
+        <p:nvSpPr>
+          <p:cNvPr id="3" name="Rectangle 2"/>
           <p:cNvSpPr/>
           <p:nvPr/>
         </p:nvSpPr>
@@ -3743,119 +3613,6 @@
             <a:ext cx="5143500" cy="9144000"/>
           </a:xfrm>
           <a:prstGeom prst="rect">
-            <a:avLst/>
-          </a:prstGeom>
-          <a:solidFill>
-            <a:srgbClr val="1A1A2E"/>
-          </a:solidFill>
-          <a:ln>
-            <a:noFill/>
-          </a:ln>
-        </p:spPr>
-        <p:style>
-          <a:lnRef idx="1">
-            <a:schemeClr val="accent1"/>
-          </a:lnRef>
-          <a:fillRef idx="3">
-            <a:schemeClr val="accent1"/>
-          </a:fillRef>
-          <a:effectRef idx="2">
-            <a:schemeClr val="accent1"/>
-          </a:effectRef>
-          <a:fontRef idx="minor">
-            <a:schemeClr val="lt1"/>
-          </a:fontRef>
-        </p:style>
-        <p:txBody>
-          <a:bodyPr rtlCol="0" anchor="ctr"/>
-          <a:lstStyle/>
-          <a:p>
-            <a:pPr algn="ctr"/>
-          </a:p>
-        </p:txBody>
-      </p:sp>
-      <p:sp>
-        <p:nvSpPr>
-          <p:cNvPr id="2" name="TextBox 1"/>
-          <p:cNvSpPr txBox="1"/>
-          <p:nvPr/>
-        </p:nvSpPr>
-        <p:spPr>
-          <a:xfrm>
-            <a:off x="514350" y="2560320"/>
-            <a:ext cx="4114800" cy="1485900"/>
-          </a:xfrm>
-          <a:prstGeom prst="rect">
-            <a:avLst/>
-          </a:prstGeom>
-          <a:noFill/>
-        </p:spPr>
-        <p:txBody>
-          <a:bodyPr wrap="square">
-            <a:spAutoFit/>
-          </a:bodyPr>
-          <a:lstStyle/>
-          <a:p>
-            <a:pPr algn="ctr">
-              <a:defRPr sz="3779" b="1">
-                <a:solidFill>
-                  <a:srgbClr val="FFFFFF"/>
-                </a:solidFill>
-              </a:defRPr>
-            </a:pPr>
-            <a:r>
-              <a:t>Call to Action</a:t>
-            </a:r>
-          </a:p>
-        </p:txBody>
-      </p:sp>
-      <p:sp>
-        <p:nvSpPr>
-          <p:cNvPr id="3" name="TextBox 2"/>
-          <p:cNvSpPr txBox="1"/>
-          <p:nvPr/>
-        </p:nvSpPr>
-        <p:spPr>
-          <a:xfrm>
-            <a:off x="514350" y="4343400"/>
-            <a:ext cx="4114800" cy="891540"/>
-          </a:xfrm>
-          <a:prstGeom prst="rect">
-            <a:avLst/>
-          </a:prstGeom>
-          <a:noFill/>
-        </p:spPr>
-        <p:txBody>
-          <a:bodyPr wrap="square">
-            <a:spAutoFit/>
-          </a:bodyPr>
-          <a:lstStyle/>
-          <a:p>
-            <a:pPr algn="ctr">
-              <a:defRPr sz="2204">
-                <a:solidFill>
-                  <a:srgbClr val="FFFFFF"/>
-                </a:solidFill>
-              </a:defRPr>
-            </a:pPr>
-            <a:r>
-              <a:t>Follow for more insights</a:t>
-            </a:r>
-          </a:p>
-        </p:txBody>
-      </p:sp>
-      <p:sp>
-        <p:nvSpPr>
-          <p:cNvPr id="4" name="Rounded Rectangle 3"/>
-          <p:cNvSpPr/>
-          <p:nvPr/>
-        </p:nvSpPr>
-        <p:spPr>
-          <a:xfrm>
-            <a:off x="1543050" y="5532120"/>
-            <a:ext cx="2057400" cy="713232"/>
-          </a:xfrm>
-          <a:prstGeom prst="roundRect">
             <a:avLst/>
           </a:prstGeom>
           <a:solidFill>

</xml_diff>